<commit_message>
Complete 3-phantom regression deck + add sim 3D CNN script
Deck (regression_deck/): slides 4 & 6 now show predicted-vs-actual across all
three phantoms (empty/F4/F5) for both LOSO and LOPO -- the full phantom x
protocol matrix. Added figures pred_vs_actual_{loso_f4,lopo_empty,lopo_f4}.png;
displayed medians synced to the enriched re-runs. QA passed (8 slides, no
defects).

Enriched result JSONs (LOSO F4, LOPO empty, LOPO F4) re-run with predX/predY
per position; medians within ~0.02in of documented (GPU run-to-run noise).

New: cnn_matlab/Imager_CNN_SimReg.m -- reuses the CNN for 3D (x,y,z) tumor
localization on the SamMakin sim (Touchstone loader, differential dS input,
fc(3) head, 8-fold position CV, xy/z-separate metrics). Feasibility confirmed
learnable (k-NN xy ~3.3mm, z ~2mm); not yet run here.

Co-Authored-By: Claude Opus 4.8 <noreply@anthropic.com>
</commit_message>
<xml_diff>
--- a/regression_deck/Regression_Results.pptx
+++ b/regression_deck/Regression_Results.pptx
@@ -197,13 +197,13 @@
                 <c:formatCode>General</c:formatCode>
                 <c:ptCount val="3"/>
                 <c:pt idx="0">
-                  <c:v>0.156</c:v>
+                  <c:v>0.154</c:v>
                 </c:pt>
                 <c:pt idx="1">
-                  <c:v>0.167</c:v>
+                  <c:v>0.164</c:v>
                 </c:pt>
                 <c:pt idx="2">
-                  <c:v>0.221</c:v>
+                  <c:v>0.223</c:v>
                 </c:pt>
               </c:numCache>
             </c:numRef>
@@ -652,13 +652,13 @@
                 <c:formatCode>General</c:formatCode>
                 <c:ptCount val="3"/>
                 <c:pt idx="0">
-                  <c:v>0.448</c:v>
+                  <c:v>0.473</c:v>
                 </c:pt>
                 <c:pt idx="1">
-                  <c:v>0.482</c:v>
+                  <c:v>0.487</c:v>
                 </c:pt>
                 <c:pt idx="2">
-                  <c:v>0.664</c:v>
+                  <c:v>0.667</c:v>
                 </c:pt>
               </c:numCache>
             </c:numRef>
@@ -4192,7 +4192,7 @@
                 <a:ea typeface="Cambria" pitchFamily="34" charset="-122"/>
                 <a:cs typeface="Cambria" pitchFamily="34" charset="-120"/>
               </a:rPr>
-              <a:t>Predicted vs. actual — LOSO</a:t>
+              <a:t>Predicted vs. actual — LOSO (all phantoms)</a:t>
             </a:r>
             <a:endParaRPr lang="en-US" sz="3000" dirty="0"/>
           </a:p>
@@ -4231,7 +4231,7 @@
                 <a:ea typeface="Calibri" pitchFamily="34" charset="-122"/>
                 <a:cs typeface="Calibri" pitchFamily="34" charset="-120"/>
               </a:rPr>
-              <a:t>Green diamonds = CNN prediction; circles = true position; arrow = the error</a:t>
+              <a:t>Green diamonds = CNN prediction · circles = true position · arrow = the error</a:t>
             </a:r>
             <a:endParaRPr lang="en-US" sz="1400" dirty="0"/>
           </a:p>
@@ -4245,12 +4245,12 @@
         </p:nvSpPr>
         <p:spPr>
           <a:xfrm>
-            <a:off x="548640" y="1554480"/>
-            <a:ext cx="5486400" cy="4709160"/>
+            <a:off x="864108" y="1627632"/>
+            <a:ext cx="3419856" cy="3950208"/>
           </a:xfrm>
           <a:prstGeom prst="roundRect">
             <a:avLst>
-              <a:gd name="adj" fmla="val 1748"/>
+              <a:gd name="adj" fmla="val 2406"/>
             </a:avLst>
           </a:prstGeom>
           <a:solidFill>
@@ -4287,8 +4287,8 @@
         </p:blipFill>
         <p:spPr>
           <a:xfrm>
-            <a:off x="868680" y="1783080"/>
-            <a:ext cx="3657600" cy="3776472"/>
+            <a:off x="973836" y="1755648"/>
+            <a:ext cx="3200400" cy="3310128"/>
           </a:xfrm>
           <a:prstGeom prst="rect">
             <a:avLst/>
@@ -4303,8 +4303,8 @@
         </p:nvSpPr>
         <p:spPr>
           <a:xfrm>
-            <a:off x="4526280" y="1965960"/>
-            <a:ext cx="1371600" cy="822960"/>
+            <a:off x="864108" y="5084064"/>
+            <a:ext cx="3419856" cy="347472"/>
           </a:xfrm>
           <a:prstGeom prst="rect">
             <a:avLst/>
@@ -4316,50 +4316,11 @@
           <a:bodyPr wrap="square" lIns="0" tIns="0" rIns="0" bIns="0" rtlCol="0" anchor="ctr"/>
           <a:lstStyle/>
           <a:p>
-            <a:pPr indent="0" marL="0">
-              <a:buNone/>
-            </a:pPr>
-            <a:r>
-              <a:rPr lang="en-US" sz="1600" b="1" dirty="0">
-                <a:solidFill>
-                  <a:srgbClr val="0B5D7A"/>
-                </a:solidFill>
-                <a:latin typeface="Cambria" pitchFamily="34" charset="0"/>
-                <a:ea typeface="Cambria" pitchFamily="34" charset="-122"/>
-                <a:cs typeface="Cambria" pitchFamily="34" charset="-120"/>
-              </a:rPr>
-              <a:t>Empty phantom</a:t>
-            </a:r>
-            <a:endParaRPr lang="en-US" sz="1600" dirty="0"/>
-          </a:p>
-        </p:txBody>
-      </p:sp>
-      <p:sp>
-        <p:nvSpPr>
-          <p:cNvPr id="7" name="Text 4"/>
-          <p:cNvSpPr/>
-          <p:nvPr/>
-        </p:nvSpPr>
-        <p:spPr>
-          <a:xfrm>
-            <a:off x="4526280" y="2834640"/>
-            <a:ext cx="1417320" cy="3108960"/>
-          </a:xfrm>
-          <a:prstGeom prst="rect">
-            <a:avLst/>
-          </a:prstGeom>
-          <a:noFill/>
-          <a:ln/>
-        </p:spPr>
-        <p:txBody>
-          <a:bodyPr wrap="square" lIns="0" tIns="0" rIns="0" bIns="0" rtlCol="0" anchor="ctr"/>
-          <a:lstStyle/>
-          <a:p>
-            <a:pPr indent="0" marL="0">
-              <a:buNone/>
-            </a:pPr>
-            <a:r>
-              <a:rPr lang="en-US" sz="1200" dirty="0">
+            <a:pPr algn="ctr" indent="0" marL="0">
+              <a:buNone/>
+            </a:pPr>
+            <a:r>
+              <a:rPr lang="en-US" sz="1300" b="1" dirty="0">
                 <a:solidFill>
                   <a:srgbClr val="1E293B"/>
                 </a:solidFill>
@@ -4367,26 +4328,40 @@
                 <a:ea typeface="Calibri" pitchFamily="34" charset="-122"/>
                 <a:cs typeface="Calibri" pitchFamily="34" charset="-120"/>
               </a:rPr>
-              <a:t>predictions sit almost on top of the true grid — arrows are tiny</a:t>
-            </a:r>
-            <a:endParaRPr lang="en-US" sz="1200" dirty="0"/>
-          </a:p>
-        </p:txBody>
-      </p:sp>
-      <p:sp>
-        <p:nvSpPr>
-          <p:cNvPr id="8" name="Shape 5"/>
-          <p:cNvSpPr/>
-          <p:nvPr/>
-        </p:nvSpPr>
-        <p:spPr>
-          <a:xfrm>
-            <a:off x="6355080" y="1554480"/>
-            <a:ext cx="5486400" cy="4709160"/>
+              <a:t>Empty   </a:t>
+            </a:r>
+            <a:pPr algn="ctr" indent="0" marL="0">
+              <a:buNone/>
+            </a:pPr>
+            <a:r>
+              <a:rPr lang="en-US" sz="1300" b="1" dirty="0">
+                <a:solidFill>
+                  <a:srgbClr val="1C9AA8"/>
+                </a:solidFill>
+                <a:latin typeface="Calibri" pitchFamily="34" charset="0"/>
+                <a:ea typeface="Calibri" pitchFamily="34" charset="-122"/>
+                <a:cs typeface="Calibri" pitchFamily="34" charset="-120"/>
+              </a:rPr>
+              <a:t>median 0.15 in</a:t>
+            </a:r>
+            <a:endParaRPr lang="en-US" sz="1300" dirty="0"/>
+          </a:p>
+        </p:txBody>
+      </p:sp>
+      <p:sp>
+        <p:nvSpPr>
+          <p:cNvPr id="7" name="Shape 4"/>
+          <p:cNvSpPr/>
+          <p:nvPr/>
+        </p:nvSpPr>
+        <p:spPr>
+          <a:xfrm>
+            <a:off x="4384548" y="1627632"/>
+            <a:ext cx="3419856" cy="3950208"/>
           </a:xfrm>
           <a:prstGeom prst="roundRect">
             <a:avLst>
-              <a:gd name="adj" fmla="val 1748"/>
+              <a:gd name="adj" fmla="val 2406"/>
             </a:avLst>
           </a:prstGeom>
           <a:solidFill>
@@ -4409,7 +4384,7 @@
       </p:sp>
       <p:pic>
         <p:nvPicPr>
-          <p:cNvPr id="9" name="Image 1" descr="pred_vs_actual_loso_f5.png">    </p:cNvPr>
+          <p:cNvPr id="8" name="Image 1" descr="pred_vs_actual_loso_f4.png">    </p:cNvPr>
           <p:cNvPicPr>
             <a:picLocks noChangeAspect="1"/>
           </p:cNvPicPr>
@@ -4423,8 +4398,8 @@
         </p:blipFill>
         <p:spPr>
           <a:xfrm>
-            <a:off x="6675120" y="1783080"/>
-            <a:ext cx="3657600" cy="3776472"/>
+            <a:off x="4494276" y="1755648"/>
+            <a:ext cx="3200400" cy="3310128"/>
           </a:xfrm>
           <a:prstGeom prst="rect">
             <a:avLst/>
@@ -4433,14 +4408,14 @@
       </p:pic>
       <p:sp>
         <p:nvSpPr>
-          <p:cNvPr id="10" name="Text 6"/>
-          <p:cNvSpPr/>
-          <p:nvPr/>
-        </p:nvSpPr>
-        <p:spPr>
-          <a:xfrm>
-            <a:off x="10332720" y="1965960"/>
-            <a:ext cx="1371600" cy="822960"/>
+          <p:cNvPr id="9" name="Text 5"/>
+          <p:cNvSpPr/>
+          <p:nvPr/>
+        </p:nvSpPr>
+        <p:spPr>
+          <a:xfrm>
+            <a:off x="4384548" y="5084064"/>
+            <a:ext cx="3419856" cy="347472"/>
           </a:xfrm>
           <a:prstGeom prst="rect">
             <a:avLst/>
@@ -4452,50 +4427,11 @@
           <a:bodyPr wrap="square" lIns="0" tIns="0" rIns="0" bIns="0" rtlCol="0" anchor="ctr"/>
           <a:lstStyle/>
           <a:p>
-            <a:pPr indent="0" marL="0">
-              <a:buNone/>
-            </a:pPr>
-            <a:r>
-              <a:rPr lang="en-US" sz="1600" b="1" dirty="0">
-                <a:solidFill>
-                  <a:srgbClr val="0B5D7A"/>
-                </a:solidFill>
-                <a:latin typeface="Cambria" pitchFamily="34" charset="0"/>
-                <a:ea typeface="Cambria" pitchFamily="34" charset="-122"/>
-                <a:cs typeface="Cambria" pitchFamily="34" charset="-120"/>
-              </a:rPr>
-              <a:t>F5 (large insert)</a:t>
-            </a:r>
-            <a:endParaRPr lang="en-US" sz="1600" dirty="0"/>
-          </a:p>
-        </p:txBody>
-      </p:sp>
-      <p:sp>
-        <p:nvSpPr>
-          <p:cNvPr id="11" name="Text 7"/>
-          <p:cNvSpPr/>
-          <p:nvPr/>
-        </p:nvSpPr>
-        <p:spPr>
-          <a:xfrm>
-            <a:off x="10332720" y="2834640"/>
-            <a:ext cx="1417320" cy="3108960"/>
-          </a:xfrm>
-          <a:prstGeom prst="rect">
-            <a:avLst/>
-          </a:prstGeom>
-          <a:noFill/>
-          <a:ln/>
-        </p:spPr>
-        <p:txBody>
-          <a:bodyPr wrap="square" lIns="0" tIns="0" rIns="0" bIns="0" rtlCol="0" anchor="ctr"/>
-          <a:lstStyle/>
-          <a:p>
-            <a:pPr indent="0" marL="0">
-              <a:buNone/>
-            </a:pPr>
-            <a:r>
-              <a:rPr lang="en-US" sz="1200" dirty="0">
+            <a:pPr algn="ctr" indent="0" marL="0">
+              <a:buNone/>
+            </a:pPr>
+            <a:r>
+              <a:rPr lang="en-US" sz="1300" b="1" dirty="0">
                 <a:solidFill>
                   <a:srgbClr val="1E293B"/>
                 </a:solidFill>
@@ -4503,9 +4439,173 @@
                 <a:ea typeface="Calibri" pitchFamily="34" charset="-122"/>
                 <a:cs typeface="Calibri" pitchFamily="34" charset="-120"/>
               </a:rPr>
-              <a:t>still tight; the few longer arrows creep toward the centre</a:t>
-            </a:r>
-            <a:endParaRPr lang="en-US" sz="1200" dirty="0"/>
+              <a:t>F4 insert   </a:t>
+            </a:r>
+            <a:pPr algn="ctr" indent="0" marL="0">
+              <a:buNone/>
+            </a:pPr>
+            <a:r>
+              <a:rPr lang="en-US" sz="1300" b="1" dirty="0">
+                <a:solidFill>
+                  <a:srgbClr val="1C9AA8"/>
+                </a:solidFill>
+                <a:latin typeface="Calibri" pitchFamily="34" charset="0"/>
+                <a:ea typeface="Calibri" pitchFamily="34" charset="-122"/>
+                <a:cs typeface="Calibri" pitchFamily="34" charset="-120"/>
+              </a:rPr>
+              <a:t>median 0.16 in</a:t>
+            </a:r>
+            <a:endParaRPr lang="en-US" sz="1300" dirty="0"/>
+          </a:p>
+        </p:txBody>
+      </p:sp>
+      <p:sp>
+        <p:nvSpPr>
+          <p:cNvPr id="10" name="Shape 6"/>
+          <p:cNvSpPr/>
+          <p:nvPr/>
+        </p:nvSpPr>
+        <p:spPr>
+          <a:xfrm>
+            <a:off x="7904988" y="1627632"/>
+            <a:ext cx="3419856" cy="3950208"/>
+          </a:xfrm>
+          <a:prstGeom prst="roundRect">
+            <a:avLst>
+              <a:gd name="adj" fmla="val 2406"/>
+            </a:avLst>
+          </a:prstGeom>
+          <a:solidFill>
+            <a:srgbClr val="F3F7FA"/>
+          </a:solidFill>
+          <a:ln w="12700">
+            <a:solidFill>
+              <a:srgbClr val="D8E2EA"/>
+            </a:solidFill>
+            <a:prstDash val="solid"/>
+          </a:ln>
+          <a:effectLst>
+            <a:outerShdw sx="100000" sy="100000" kx="0" ky="0" algn="bl" rotWithShape="0" blurRad="88900" dist="38100" dir="5400000">
+              <a:srgbClr val="5B6B7B">
+                <a:alpha val="18000"/>
+              </a:srgbClr>
+            </a:outerShdw>
+          </a:effectLst>
+        </p:spPr>
+      </p:sp>
+      <p:pic>
+        <p:nvPicPr>
+          <p:cNvPr id="11" name="Image 2" descr="pred_vs_actual_loso_f5.png">    </p:cNvPr>
+          <p:cNvPicPr>
+            <a:picLocks noChangeAspect="1"/>
+          </p:cNvPicPr>
+          <p:nvPr/>
+        </p:nvPicPr>
+        <p:blipFill>
+          <a:blip r:embed="rId3"/>
+          <a:stretch>
+            <a:fillRect/>
+          </a:stretch>
+        </p:blipFill>
+        <p:spPr>
+          <a:xfrm>
+            <a:off x="8014716" y="1755648"/>
+            <a:ext cx="3200400" cy="3310128"/>
+          </a:xfrm>
+          <a:prstGeom prst="rect">
+            <a:avLst/>
+          </a:prstGeom>
+        </p:spPr>
+      </p:pic>
+      <p:sp>
+        <p:nvSpPr>
+          <p:cNvPr id="12" name="Text 7"/>
+          <p:cNvSpPr/>
+          <p:nvPr/>
+        </p:nvSpPr>
+        <p:spPr>
+          <a:xfrm>
+            <a:off x="7904988" y="5084064"/>
+            <a:ext cx="3419856" cy="347472"/>
+          </a:xfrm>
+          <a:prstGeom prst="rect">
+            <a:avLst/>
+          </a:prstGeom>
+          <a:noFill/>
+          <a:ln/>
+        </p:spPr>
+        <p:txBody>
+          <a:bodyPr wrap="square" lIns="0" tIns="0" rIns="0" bIns="0" rtlCol="0" anchor="ctr"/>
+          <a:lstStyle/>
+          <a:p>
+            <a:pPr algn="ctr" indent="0" marL="0">
+              <a:buNone/>
+            </a:pPr>
+            <a:r>
+              <a:rPr lang="en-US" sz="1300" b="1" dirty="0">
+                <a:solidFill>
+                  <a:srgbClr val="1E293B"/>
+                </a:solidFill>
+                <a:latin typeface="Calibri" pitchFamily="34" charset="0"/>
+                <a:ea typeface="Calibri" pitchFamily="34" charset="-122"/>
+                <a:cs typeface="Calibri" pitchFamily="34" charset="-120"/>
+              </a:rPr>
+              <a:t>F5 insert   </a:t>
+            </a:r>
+            <a:pPr algn="ctr" indent="0" marL="0">
+              <a:buNone/>
+            </a:pPr>
+            <a:r>
+              <a:rPr lang="en-US" sz="1300" b="1" dirty="0">
+                <a:solidFill>
+                  <a:srgbClr val="1C9AA8"/>
+                </a:solidFill>
+                <a:latin typeface="Calibri" pitchFamily="34" charset="0"/>
+                <a:ea typeface="Calibri" pitchFamily="34" charset="-122"/>
+                <a:cs typeface="Calibri" pitchFamily="34" charset="-120"/>
+              </a:rPr>
+              <a:t>median 0.22 in</a:t>
+            </a:r>
+            <a:endParaRPr lang="en-US" sz="1300" dirty="0"/>
+          </a:p>
+        </p:txBody>
+      </p:sp>
+      <p:sp>
+        <p:nvSpPr>
+          <p:cNvPr id="13" name="Text 8"/>
+          <p:cNvSpPr/>
+          <p:nvPr/>
+        </p:nvSpPr>
+        <p:spPr>
+          <a:xfrm>
+            <a:off x="548640" y="6144768"/>
+            <a:ext cx="11091672" cy="457200"/>
+          </a:xfrm>
+          <a:prstGeom prst="rect">
+            <a:avLst/>
+          </a:prstGeom>
+          <a:noFill/>
+          <a:ln/>
+        </p:spPr>
+        <p:txBody>
+          <a:bodyPr wrap="square" lIns="0" tIns="0" rIns="0" bIns="0" rtlCol="0" anchor="ctr"/>
+          <a:lstStyle/>
+          <a:p>
+            <a:pPr algn="ctr" indent="0" marL="0">
+              <a:buNone/>
+            </a:pPr>
+            <a:r>
+              <a:rPr lang="en-US" sz="1350" i="1" dirty="0">
+                <a:solidFill>
+                  <a:srgbClr val="5B6B7B"/>
+                </a:solidFill>
+                <a:latin typeface="Calibri" pitchFamily="34" charset="0"/>
+                <a:ea typeface="Calibri" pitchFamily="34" charset="-122"/>
+                <a:cs typeface="Calibri" pitchFamily="34" charset="-120"/>
+              </a:rPr>
+              <a:t>Across empty, small (F4) and large (F5) inserts the CNN lands within a fifth of a cell — a new measurement session is not a problem.</a:t>
+            </a:r>
+            <a:endParaRPr lang="en-US" sz="1350" dirty="0"/>
           </a:p>
         </p:txBody>
       </p:sp>
@@ -4855,7 +4955,7 @@
                 <a:ea typeface="Cambria" pitchFamily="34" charset="-122"/>
                 <a:cs typeface="Cambria" pitchFamily="34" charset="-120"/>
               </a:rPr>
-              <a:t>Predicted vs. actual — LOPO (F5, unseen cells)</a:t>
+              <a:t>Predicted vs. actual — LOPO (all phantoms, unseen cells)</a:t>
             </a:r>
             <a:endParaRPr lang="en-US" sz="3000" dirty="0"/>
           </a:p>
@@ -4894,7 +4994,7 @@
                 <a:ea typeface="Calibri" pitchFamily="34" charset="-122"/>
                 <a:cs typeface="Calibri" pitchFamily="34" charset="-120"/>
               </a:rPr>
-              <a:t>Now the arrows are long, and they point inward — the model can't interpolate across the dielectric barrier</a:t>
+              <a:t>Now predicting locations never sampled — arrows grow and pull inward; red-ringed points sit over the glandular insert</a:t>
             </a:r>
             <a:endParaRPr lang="en-US" sz="1400" dirty="0"/>
           </a:p>
@@ -4908,12 +5008,12 @@
         </p:nvSpPr>
         <p:spPr>
           <a:xfrm>
-            <a:off x="548640" y="1554480"/>
-            <a:ext cx="5394960" cy="4709160"/>
+            <a:off x="864108" y="1627632"/>
+            <a:ext cx="3419856" cy="3950208"/>
           </a:xfrm>
           <a:prstGeom prst="roundRect">
             <a:avLst>
-              <a:gd name="adj" fmla="val 1748"/>
+              <a:gd name="adj" fmla="val 2406"/>
             </a:avLst>
           </a:prstGeom>
           <a:solidFill>
@@ -4936,7 +5036,7 @@
       </p:sp>
       <p:pic>
         <p:nvPicPr>
-          <p:cNvPr id="5" name="Image 0" descr="pred_vs_actual_lopo_f5.png">    </p:cNvPr>
+          <p:cNvPr id="5" name="Image 0" descr="pred_vs_actual_lopo_empty.png">    </p:cNvPr>
           <p:cNvPicPr>
             <a:picLocks noChangeAspect="1"/>
           </p:cNvPicPr>
@@ -4950,8 +5050,8 @@
         </p:blipFill>
         <p:spPr>
           <a:xfrm>
-            <a:off x="868680" y="1783080"/>
-            <a:ext cx="4206240" cy="4343400"/>
+            <a:off x="973836" y="1755648"/>
+            <a:ext cx="3200400" cy="3310128"/>
           </a:xfrm>
           <a:prstGeom prst="rect">
             <a:avLst/>
@@ -4960,18 +5060,71 @@
       </p:pic>
       <p:sp>
         <p:nvSpPr>
-          <p:cNvPr id="6" name="Shape 3"/>
-          <p:cNvSpPr/>
-          <p:nvPr/>
-        </p:nvSpPr>
-        <p:spPr>
-          <a:xfrm>
-            <a:off x="6172200" y="1554480"/>
-            <a:ext cx="5440680" cy="4709160"/>
+          <p:cNvPr id="6" name="Text 3"/>
+          <p:cNvSpPr/>
+          <p:nvPr/>
+        </p:nvSpPr>
+        <p:spPr>
+          <a:xfrm>
+            <a:off x="864108" y="5084064"/>
+            <a:ext cx="3419856" cy="347472"/>
+          </a:xfrm>
+          <a:prstGeom prst="rect">
+            <a:avLst/>
+          </a:prstGeom>
+          <a:noFill/>
+          <a:ln/>
+        </p:spPr>
+        <p:txBody>
+          <a:bodyPr wrap="square" lIns="0" tIns="0" rIns="0" bIns="0" rtlCol="0" anchor="ctr"/>
+          <a:lstStyle/>
+          <a:p>
+            <a:pPr algn="ctr" indent="0" marL="0">
+              <a:buNone/>
+            </a:pPr>
+            <a:r>
+              <a:rPr lang="en-US" sz="1300" b="1" dirty="0">
+                <a:solidFill>
+                  <a:srgbClr val="1E293B"/>
+                </a:solidFill>
+                <a:latin typeface="Calibri" pitchFamily="34" charset="0"/>
+                <a:ea typeface="Calibri" pitchFamily="34" charset="-122"/>
+                <a:cs typeface="Calibri" pitchFamily="34" charset="-120"/>
+              </a:rPr>
+              <a:t>Empty   </a:t>
+            </a:r>
+            <a:pPr algn="ctr" indent="0" marL="0">
+              <a:buNone/>
+            </a:pPr>
+            <a:r>
+              <a:rPr lang="en-US" sz="1300" b="1" dirty="0">
+                <a:solidFill>
+                  <a:srgbClr val="1C9AA8"/>
+                </a:solidFill>
+                <a:latin typeface="Calibri" pitchFamily="34" charset="0"/>
+                <a:ea typeface="Calibri" pitchFamily="34" charset="-122"/>
+                <a:cs typeface="Calibri" pitchFamily="34" charset="-120"/>
+              </a:rPr>
+              <a:t>median 0.47 in</a:t>
+            </a:r>
+            <a:endParaRPr lang="en-US" sz="1300" dirty="0"/>
+          </a:p>
+        </p:txBody>
+      </p:sp>
+      <p:sp>
+        <p:nvSpPr>
+          <p:cNvPr id="7" name="Shape 4"/>
+          <p:cNvSpPr/>
+          <p:nvPr/>
+        </p:nvSpPr>
+        <p:spPr>
+          <a:xfrm>
+            <a:off x="4384548" y="1627632"/>
+            <a:ext cx="3419856" cy="3950208"/>
           </a:xfrm>
           <a:prstGeom prst="roundRect">
             <a:avLst>
-              <a:gd name="adj" fmla="val 1748"/>
+              <a:gd name="adj" fmla="val 2406"/>
             </a:avLst>
           </a:prstGeom>
           <a:solidFill>
@@ -4992,16 +5145,40 @@
           </a:effectLst>
         </p:spPr>
       </p:sp>
-      <p:sp>
-        <p:nvSpPr>
-          <p:cNvPr id="7" name="Text 4"/>
-          <p:cNvSpPr/>
-          <p:nvPr/>
-        </p:nvSpPr>
-        <p:spPr>
-          <a:xfrm>
-            <a:off x="6492240" y="1783080"/>
-            <a:ext cx="4846320" cy="457200"/>
+      <p:pic>
+        <p:nvPicPr>
+          <p:cNvPr id="8" name="Image 1" descr="pred_vs_actual_lopo_f4.png">    </p:cNvPr>
+          <p:cNvPicPr>
+            <a:picLocks noChangeAspect="1"/>
+          </p:cNvPicPr>
+          <p:nvPr/>
+        </p:nvPicPr>
+        <p:blipFill>
+          <a:blip r:embed="rId2"/>
+          <a:stretch>
+            <a:fillRect/>
+          </a:stretch>
+        </p:blipFill>
+        <p:spPr>
+          <a:xfrm>
+            <a:off x="4494276" y="1755648"/>
+            <a:ext cx="3200400" cy="3310128"/>
+          </a:xfrm>
+          <a:prstGeom prst="rect">
+            <a:avLst/>
+          </a:prstGeom>
+        </p:spPr>
+      </p:pic>
+      <p:sp>
+        <p:nvSpPr>
+          <p:cNvPr id="9" name="Text 5"/>
+          <p:cNvSpPr/>
+          <p:nvPr/>
+        </p:nvSpPr>
+        <p:spPr>
+          <a:xfrm>
+            <a:off x="4384548" y="5084064"/>
+            <a:ext cx="3419856" cy="347472"/>
           </a:xfrm>
           <a:prstGeom prst="rect">
             <a:avLst/>
@@ -5013,54 +5190,11 @@
           <a:bodyPr wrap="square" lIns="0" tIns="0" rIns="0" bIns="0" rtlCol="0" anchor="ctr"/>
           <a:lstStyle/>
           <a:p>
-            <a:pPr indent="0" marL="0">
-              <a:buNone/>
-            </a:pPr>
-            <a:r>
-              <a:rPr lang="en-US" sz="1800" b="1" dirty="0">
-                <a:solidFill>
-                  <a:srgbClr val="D64545"/>
-                </a:solidFill>
-                <a:latin typeface="Cambria" pitchFamily="34" charset="0"/>
-                <a:ea typeface="Cambria" pitchFamily="34" charset="-122"/>
-                <a:cs typeface="Cambria" pitchFamily="34" charset="-120"/>
-              </a:rPr>
-              <a:t>Reading the picture</a:t>
-            </a:r>
-            <a:endParaRPr lang="en-US" sz="1800" dirty="0"/>
-          </a:p>
-        </p:txBody>
-      </p:sp>
-      <p:sp>
-        <p:nvSpPr>
-          <p:cNvPr id="8" name="Text 5"/>
-          <p:cNvSpPr/>
-          <p:nvPr/>
-        </p:nvSpPr>
-        <p:spPr>
-          <a:xfrm>
-            <a:off x="6492240" y="2331720"/>
-            <a:ext cx="4846320" cy="3749040"/>
-          </a:xfrm>
-          <a:prstGeom prst="rect">
-            <a:avLst/>
-          </a:prstGeom>
-          <a:noFill/>
-          <a:ln/>
-        </p:spPr>
-        <p:txBody>
-          <a:bodyPr wrap="square" lIns="0" tIns="0" rIns="0" bIns="0" rtlCol="0" anchor="t"/>
-          <a:lstStyle/>
-          <a:p>
-            <a:pPr marL="342900" indent="-342900">
-              <a:spcAft>
-                <a:spcPts val="1000"/>
-              </a:spcAft>
-              <a:buSzPct val="100000"/>
-              <a:buChar char="•"/>
-            </a:pPr>
-            <a:r>
-              <a:rPr lang="en-US" sz="1350" dirty="0">
+            <a:pPr algn="ctr" indent="0" marL="0">
+              <a:buNone/>
+            </a:pPr>
+            <a:r>
+              <a:rPr lang="en-US" sz="1300" b="1" dirty="0">
                 <a:solidFill>
                   <a:srgbClr val="1E293B"/>
                 </a:solidFill>
@@ -5068,38 +5202,110 @@
                 <a:ea typeface="Calibri" pitchFamily="34" charset="-122"/>
                 <a:cs typeface="Calibri" pitchFamily="34" charset="-120"/>
               </a:rPr>
-              <a:t>Every held-out cell's prediction is dragged toward the phantom centre — the classic ill-posed-interpolation signature.</a:t>
-            </a:r>
-            <a:endParaRPr lang="en-US" sz="1350" dirty="0"/>
-          </a:p>
-          <a:p>
-            <a:pPr marL="342900" indent="-342900">
-              <a:spcAft>
-                <a:spcPts val="1000"/>
-              </a:spcAft>
-              <a:buSzPct val="100000"/>
-              <a:buChar char="•"/>
-            </a:pPr>
-            <a:r>
-              <a:rPr lang="en-US" sz="1350" dirty="0">
-                <a:solidFill>
-                  <a:srgbClr val="1E293B"/>
+              <a:t>F4 insert   </a:t>
+            </a:r>
+            <a:pPr algn="ctr" indent="0" marL="0">
+              <a:buNone/>
+            </a:pPr>
+            <a:r>
+              <a:rPr lang="en-US" sz="1300" b="1" dirty="0">
+                <a:solidFill>
+                  <a:srgbClr val="1C9AA8"/>
                 </a:solidFill>
                 <a:latin typeface="Calibri" pitchFamily="34" charset="0"/>
                 <a:ea typeface="Calibri" pitchFamily="34" charset="-122"/>
                 <a:cs typeface="Calibri" pitchFamily="34" charset="-120"/>
               </a:rPr>
-              <a:t>Red-ringed (near-insert) points have the longest arrows: the sharp dielectric change at the glandular boundary makes the field non-smooth, so the CNN can't bridge the gap.</a:t>
-            </a:r>
-            <a:endParaRPr lang="en-US" sz="1350" dirty="0"/>
-          </a:p>
-          <a:p>
-            <a:pPr marL="342900" indent="-342900">
-              <a:buSzPct val="100000"/>
-              <a:buChar char="•"/>
-            </a:pPr>
-            <a:r>
-              <a:rPr lang="en-US" sz="1350" dirty="0">
+              <a:t>median 0.49 in</a:t>
+            </a:r>
+            <a:endParaRPr lang="en-US" sz="1300" dirty="0"/>
+          </a:p>
+        </p:txBody>
+      </p:sp>
+      <p:sp>
+        <p:nvSpPr>
+          <p:cNvPr id="10" name="Shape 6"/>
+          <p:cNvSpPr/>
+          <p:nvPr/>
+        </p:nvSpPr>
+        <p:spPr>
+          <a:xfrm>
+            <a:off x="7904988" y="1627632"/>
+            <a:ext cx="3419856" cy="3950208"/>
+          </a:xfrm>
+          <a:prstGeom prst="roundRect">
+            <a:avLst>
+              <a:gd name="adj" fmla="val 2406"/>
+            </a:avLst>
+          </a:prstGeom>
+          <a:solidFill>
+            <a:srgbClr val="F3F7FA"/>
+          </a:solidFill>
+          <a:ln w="12700">
+            <a:solidFill>
+              <a:srgbClr val="D8E2EA"/>
+            </a:solidFill>
+            <a:prstDash val="solid"/>
+          </a:ln>
+          <a:effectLst>
+            <a:outerShdw sx="100000" sy="100000" kx="0" ky="0" algn="bl" rotWithShape="0" blurRad="88900" dist="38100" dir="5400000">
+              <a:srgbClr val="5B6B7B">
+                <a:alpha val="18000"/>
+              </a:srgbClr>
+            </a:outerShdw>
+          </a:effectLst>
+        </p:spPr>
+      </p:sp>
+      <p:pic>
+        <p:nvPicPr>
+          <p:cNvPr id="11" name="Image 2" descr="pred_vs_actual_lopo_f5.png">    </p:cNvPr>
+          <p:cNvPicPr>
+            <a:picLocks noChangeAspect="1"/>
+          </p:cNvPicPr>
+          <p:nvPr/>
+        </p:nvPicPr>
+        <p:blipFill>
+          <a:blip r:embed="rId3"/>
+          <a:stretch>
+            <a:fillRect/>
+          </a:stretch>
+        </p:blipFill>
+        <p:spPr>
+          <a:xfrm>
+            <a:off x="8014716" y="1755648"/>
+            <a:ext cx="3200400" cy="3310128"/>
+          </a:xfrm>
+          <a:prstGeom prst="rect">
+            <a:avLst/>
+          </a:prstGeom>
+        </p:spPr>
+      </p:pic>
+      <p:sp>
+        <p:nvSpPr>
+          <p:cNvPr id="12" name="Text 7"/>
+          <p:cNvSpPr/>
+          <p:nvPr/>
+        </p:nvSpPr>
+        <p:spPr>
+          <a:xfrm>
+            <a:off x="7904988" y="5084064"/>
+            <a:ext cx="3419856" cy="347472"/>
+          </a:xfrm>
+          <a:prstGeom prst="rect">
+            <a:avLst/>
+          </a:prstGeom>
+          <a:noFill/>
+          <a:ln/>
+        </p:spPr>
+        <p:txBody>
+          <a:bodyPr wrap="square" lIns="0" tIns="0" rIns="0" bIns="0" rtlCol="0" anchor="ctr"/>
+          <a:lstStyle/>
+          <a:p>
+            <a:pPr algn="ctr" indent="0" marL="0">
+              <a:buNone/>
+            </a:pPr>
+            <a:r>
+              <a:rPr lang="en-US" sz="1300" b="1" dirty="0">
                 <a:solidFill>
                   <a:srgbClr val="1E293B"/>
                 </a:solidFill>
@@ -5107,7 +5313,60 @@
                 <a:ea typeface="Calibri" pitchFamily="34" charset="-122"/>
                 <a:cs typeface="Calibri" pitchFamily="34" charset="-120"/>
               </a:rPr>
-              <a:t>This is the physics the session-transfer test hid — every position (insert included) was in LOSO training, so the model had memorized it.</a:t>
+              <a:t>F5 insert   </a:t>
+            </a:r>
+            <a:pPr algn="ctr" indent="0" marL="0">
+              <a:buNone/>
+            </a:pPr>
+            <a:r>
+              <a:rPr lang="en-US" sz="1300" b="1" dirty="0">
+                <a:solidFill>
+                  <a:srgbClr val="1C9AA8"/>
+                </a:solidFill>
+                <a:latin typeface="Calibri" pitchFamily="34" charset="0"/>
+                <a:ea typeface="Calibri" pitchFamily="34" charset="-122"/>
+                <a:cs typeface="Calibri" pitchFamily="34" charset="-120"/>
+              </a:rPr>
+              <a:t>median 0.67 in</a:t>
+            </a:r>
+            <a:endParaRPr lang="en-US" sz="1300" dirty="0"/>
+          </a:p>
+        </p:txBody>
+      </p:sp>
+      <p:sp>
+        <p:nvSpPr>
+          <p:cNvPr id="13" name="Text 8"/>
+          <p:cNvSpPr/>
+          <p:nvPr/>
+        </p:nvSpPr>
+        <p:spPr>
+          <a:xfrm>
+            <a:off x="548640" y="6144768"/>
+            <a:ext cx="11091672" cy="457200"/>
+          </a:xfrm>
+          <a:prstGeom prst="rect">
+            <a:avLst/>
+          </a:prstGeom>
+          <a:noFill/>
+          <a:ln/>
+        </p:spPr>
+        <p:txBody>
+          <a:bodyPr wrap="square" lIns="0" tIns="0" rIns="0" bIns="0" rtlCol="0" anchor="ctr"/>
+          <a:lstStyle/>
+          <a:p>
+            <a:pPr algn="ctr" indent="0" marL="0">
+              <a:buNone/>
+            </a:pPr>
+            <a:r>
+              <a:rPr lang="en-US" sz="1350" i="1" dirty="0">
+                <a:solidFill>
+                  <a:srgbClr val="5B6B7B"/>
+                </a:solidFill>
+                <a:latin typeface="Calibri" pitchFamily="34" charset="0"/>
+                <a:ea typeface="Calibri" pitchFamily="34" charset="-122"/>
+                <a:cs typeface="Calibri" pitchFamily="34" charset="-120"/>
+              </a:rPr>
+              <a:t>Interpolation error climbs with insert size (0.47 → 0.49 → 0.67 in) and concentrates on the near-insert cells — the CNN can't bridge the dielectric barrier it never sampled.</a:t>
             </a:r>
             <a:endParaRPr lang="en-US" sz="1350" dirty="0"/>
           </a:p>

</xml_diff>